<commit_message>
RIC-1437: Doc and tests update
</commit_message>
<xml_diff>
--- a/illustrations.pptx
+++ b/illustrations.pptx
@@ -5,7 +5,7 @@
     <p:sldMasterId id="2147483648" r:id="rId1"/>
   </p:sldMasterIdLst>
   <p:notesMasterIdLst>
-    <p:notesMasterId r:id="rId31"/>
+    <p:notesMasterId r:id="rId32"/>
   </p:notesMasterIdLst>
   <p:sldIdLst>
     <p:sldId id="256" r:id="rId2"/>
@@ -37,6 +37,7 @@
     <p:sldId id="281" r:id="rId28"/>
     <p:sldId id="283" r:id="rId29"/>
     <p:sldId id="284" r:id="rId30"/>
+    <p:sldId id="285" r:id="rId31"/>
   </p:sldIdLst>
   <p:sldSz cx="12192000" cy="6858000"/>
   <p:notesSz cx="6858000" cy="9144000"/>
@@ -225,7 +226,7 @@
           <a:p>
             <a:fld id="{62B5D429-15EF-4A8F-AA09-BECBB0A557A5}" type="datetimeFigureOut">
               <a:rPr lang="en-IN" smtClean="0"/>
-              <a:t>02-09-2024</a:t>
+              <a:t>16-10-2025</a:t>
             </a:fld>
             <a:endParaRPr lang="en-IN"/>
           </a:p>
@@ -10499,7 +10500,7 @@
           <a:p>
             <a:fld id="{35051988-DCA8-486F-804A-657BF6D379C2}" type="datetimeFigureOut">
               <a:rPr lang="en-IN" smtClean="0"/>
-              <a:t>02-09-2024</a:t>
+              <a:t>16-10-2025</a:t>
             </a:fld>
             <a:endParaRPr lang="en-IN"/>
           </a:p>
@@ -10699,7 +10700,7 @@
           <a:p>
             <a:fld id="{35051988-DCA8-486F-804A-657BF6D379C2}" type="datetimeFigureOut">
               <a:rPr lang="en-IN" smtClean="0"/>
-              <a:t>02-09-2024</a:t>
+              <a:t>16-10-2025</a:t>
             </a:fld>
             <a:endParaRPr lang="en-IN"/>
           </a:p>
@@ -10909,7 +10910,7 @@
           <a:p>
             <a:fld id="{35051988-DCA8-486F-804A-657BF6D379C2}" type="datetimeFigureOut">
               <a:rPr lang="en-IN" smtClean="0"/>
-              <a:t>02-09-2024</a:t>
+              <a:t>16-10-2025</a:t>
             </a:fld>
             <a:endParaRPr lang="en-IN"/>
           </a:p>
@@ -11109,7 +11110,7 @@
           <a:p>
             <a:fld id="{35051988-DCA8-486F-804A-657BF6D379C2}" type="datetimeFigureOut">
               <a:rPr lang="en-IN" smtClean="0"/>
-              <a:t>02-09-2024</a:t>
+              <a:t>16-10-2025</a:t>
             </a:fld>
             <a:endParaRPr lang="en-IN"/>
           </a:p>
@@ -11385,7 +11386,7 @@
           <a:p>
             <a:fld id="{35051988-DCA8-486F-804A-657BF6D379C2}" type="datetimeFigureOut">
               <a:rPr lang="en-IN" smtClean="0"/>
-              <a:t>02-09-2024</a:t>
+              <a:t>16-10-2025</a:t>
             </a:fld>
             <a:endParaRPr lang="en-IN"/>
           </a:p>
@@ -11653,7 +11654,7 @@
           <a:p>
             <a:fld id="{35051988-DCA8-486F-804A-657BF6D379C2}" type="datetimeFigureOut">
               <a:rPr lang="en-IN" smtClean="0"/>
-              <a:t>02-09-2024</a:t>
+              <a:t>16-10-2025</a:t>
             </a:fld>
             <a:endParaRPr lang="en-IN"/>
           </a:p>
@@ -12068,7 +12069,7 @@
           <a:p>
             <a:fld id="{35051988-DCA8-486F-804A-657BF6D379C2}" type="datetimeFigureOut">
               <a:rPr lang="en-IN" smtClean="0"/>
-              <a:t>02-09-2024</a:t>
+              <a:t>16-10-2025</a:t>
             </a:fld>
             <a:endParaRPr lang="en-IN"/>
           </a:p>
@@ -12210,7 +12211,7 @@
           <a:p>
             <a:fld id="{35051988-DCA8-486F-804A-657BF6D379C2}" type="datetimeFigureOut">
               <a:rPr lang="en-IN" smtClean="0"/>
-              <a:t>02-09-2024</a:t>
+              <a:t>16-10-2025</a:t>
             </a:fld>
             <a:endParaRPr lang="en-IN"/>
           </a:p>
@@ -12323,7 +12324,7 @@
           <a:p>
             <a:fld id="{35051988-DCA8-486F-804A-657BF6D379C2}" type="datetimeFigureOut">
               <a:rPr lang="en-IN" smtClean="0"/>
-              <a:t>02-09-2024</a:t>
+              <a:t>16-10-2025</a:t>
             </a:fld>
             <a:endParaRPr lang="en-IN"/>
           </a:p>
@@ -12636,7 +12637,7 @@
           <a:p>
             <a:fld id="{35051988-DCA8-486F-804A-657BF6D379C2}" type="datetimeFigureOut">
               <a:rPr lang="en-IN" smtClean="0"/>
-              <a:t>02-09-2024</a:t>
+              <a:t>16-10-2025</a:t>
             </a:fld>
             <a:endParaRPr lang="en-IN"/>
           </a:p>
@@ -12925,7 +12926,7 @@
           <a:p>
             <a:fld id="{35051988-DCA8-486F-804A-657BF6D379C2}" type="datetimeFigureOut">
               <a:rPr lang="en-IN" smtClean="0"/>
-              <a:t>02-09-2024</a:t>
+              <a:t>16-10-2025</a:t>
             </a:fld>
             <a:endParaRPr lang="en-IN"/>
           </a:p>
@@ -13168,7 +13169,7 @@
           <a:p>
             <a:fld id="{35051988-DCA8-486F-804A-657BF6D379C2}" type="datetimeFigureOut">
               <a:rPr lang="en-IN" smtClean="0"/>
-              <a:t>02-09-2024</a:t>
+              <a:t>16-10-2025</a:t>
             </a:fld>
             <a:endParaRPr lang="en-IN"/>
           </a:p>
@@ -19796,6 +19797,897 @@
 </p:sld>
 </file>
 
+<file path=ppt/slides/slide30.xml><?xml version="1.0" encoding="utf-8"?>
+<p:sld xmlns:a="http://schemas.openxmlformats.org/drawingml/2006/main" xmlns:r="http://schemas.openxmlformats.org/officeDocument/2006/relationships" xmlns:p="http://schemas.openxmlformats.org/presentationml/2006/main">
+  <p:cSld>
+    <p:spTree>
+      <p:nvGrpSpPr>
+        <p:cNvPr id="1" name=""/>
+        <p:cNvGrpSpPr/>
+        <p:nvPr/>
+      </p:nvGrpSpPr>
+      <p:grpSpPr>
+        <a:xfrm>
+          <a:off x="0" y="0"/>
+          <a:ext cx="0" cy="0"/>
+          <a:chOff x="0" y="0"/>
+          <a:chExt cx="0" cy="0"/>
+        </a:xfrm>
+      </p:grpSpPr>
+      <p:pic>
+        <p:nvPicPr>
+          <p:cNvPr id="32" name="Picture 31">
+            <a:extLst>
+              <a:ext uri="{FF2B5EF4-FFF2-40B4-BE49-F238E27FC236}">
+                <a16:creationId xmlns:a16="http://schemas.microsoft.com/office/drawing/2014/main" id="{C64DFEC3-637C-0F53-22E3-6A897CFB5CC0}"/>
+              </a:ext>
+            </a:extLst>
+          </p:cNvPr>
+          <p:cNvPicPr>
+            <a:picLocks noChangeAspect="1"/>
+          </p:cNvPicPr>
+          <p:nvPr/>
+        </p:nvPicPr>
+        <p:blipFill>
+          <a:blip r:embed="rId2"/>
+          <a:stretch>
+            <a:fillRect/>
+          </a:stretch>
+        </p:blipFill>
+        <p:spPr>
+          <a:xfrm>
+            <a:off x="3098741" y="1989365"/>
+            <a:ext cx="5649113" cy="1257475"/>
+          </a:xfrm>
+          <a:prstGeom prst="rect">
+            <a:avLst/>
+          </a:prstGeom>
+        </p:spPr>
+      </p:pic>
+      <p:sp>
+        <p:nvSpPr>
+          <p:cNvPr id="6" name="TextBox 5">
+            <a:extLst>
+              <a:ext uri="{FF2B5EF4-FFF2-40B4-BE49-F238E27FC236}">
+                <a16:creationId xmlns:a16="http://schemas.microsoft.com/office/drawing/2014/main" id="{FFBC163B-7753-F4D6-A298-4076A56063EE}"/>
+              </a:ext>
+            </a:extLst>
+          </p:cNvPr>
+          <p:cNvSpPr txBox="1"/>
+          <p:nvPr/>
+        </p:nvSpPr>
+        <p:spPr>
+          <a:xfrm>
+            <a:off x="5707510" y="2430711"/>
+            <a:ext cx="858055" cy="338554"/>
+          </a:xfrm>
+          <a:prstGeom prst="rect">
+            <a:avLst/>
+          </a:prstGeom>
+          <a:noFill/>
+        </p:spPr>
+        <p:txBody>
+          <a:bodyPr wrap="none" rtlCol="0">
+            <a:spAutoFit/>
+          </a:bodyPr>
+          <a:lstStyle/>
+          <a:p>
+            <a:r>
+              <a:rPr lang="sv-SE" sz="1600" dirty="0">
+                <a:solidFill>
+                  <a:schemeClr val="accent4">
+                    <a:lumMod val="60000"/>
+                    <a:lumOff val="40000"/>
+                  </a:schemeClr>
+                </a:solidFill>
+              </a:rPr>
+              <a:t>receiver</a:t>
+            </a:r>
+            <a:endParaRPr lang="en-SE" sz="1600" dirty="0">
+              <a:solidFill>
+                <a:schemeClr val="accent4">
+                  <a:lumMod val="60000"/>
+                  <a:lumOff val="40000"/>
+                </a:schemeClr>
+              </a:solidFill>
+            </a:endParaRPr>
+          </a:p>
+        </p:txBody>
+      </p:sp>
+      <p:cxnSp>
+        <p:nvCxnSpPr>
+          <p:cNvPr id="7" name="Straight Arrow Connector 6">
+            <a:extLst>
+              <a:ext uri="{FF2B5EF4-FFF2-40B4-BE49-F238E27FC236}">
+                <a16:creationId xmlns:a16="http://schemas.microsoft.com/office/drawing/2014/main" id="{B2A2263F-A9A1-3E9A-BC34-8A4DD1C2FFE1}"/>
+              </a:ext>
+            </a:extLst>
+          </p:cNvPr>
+          <p:cNvCxnSpPr>
+            <a:cxnSpLocks/>
+          </p:cNvCxnSpPr>
+          <p:nvPr/>
+        </p:nvCxnSpPr>
+        <p:spPr>
+          <a:xfrm>
+            <a:off x="4879639" y="2829062"/>
+            <a:ext cx="0" cy="191549"/>
+          </a:xfrm>
+          <a:prstGeom prst="straightConnector1">
+            <a:avLst/>
+          </a:prstGeom>
+          <a:ln>
+            <a:solidFill>
+              <a:schemeClr val="accent4"/>
+            </a:solidFill>
+            <a:tailEnd type="triangle"/>
+          </a:ln>
+        </p:spPr>
+        <p:style>
+          <a:lnRef idx="1">
+            <a:schemeClr val="accent1"/>
+          </a:lnRef>
+          <a:fillRef idx="0">
+            <a:schemeClr val="accent1"/>
+          </a:fillRef>
+          <a:effectRef idx="0">
+            <a:schemeClr val="accent1"/>
+          </a:effectRef>
+          <a:fontRef idx="minor">
+            <a:schemeClr val="tx1"/>
+          </a:fontRef>
+        </p:style>
+      </p:cxnSp>
+      <p:sp>
+        <p:nvSpPr>
+          <p:cNvPr id="8" name="TextBox 7">
+            <a:extLst>
+              <a:ext uri="{FF2B5EF4-FFF2-40B4-BE49-F238E27FC236}">
+                <a16:creationId xmlns:a16="http://schemas.microsoft.com/office/drawing/2014/main" id="{87CC266E-04D4-C0F0-3711-B93A5A3B6C88}"/>
+              </a:ext>
+            </a:extLst>
+          </p:cNvPr>
+          <p:cNvSpPr txBox="1"/>
+          <p:nvPr/>
+        </p:nvSpPr>
+        <p:spPr>
+          <a:xfrm>
+            <a:off x="4530981" y="2309806"/>
+            <a:ext cx="803425" cy="584775"/>
+          </a:xfrm>
+          <a:prstGeom prst="rect">
+            <a:avLst/>
+          </a:prstGeom>
+          <a:noFill/>
+        </p:spPr>
+        <p:txBody>
+          <a:bodyPr wrap="none" rtlCol="0">
+            <a:spAutoFit/>
+          </a:bodyPr>
+          <a:lstStyle/>
+          <a:p>
+            <a:pPr algn="ctr"/>
+            <a:r>
+              <a:rPr lang="sv-SE" sz="1600" dirty="0">
+                <a:solidFill>
+                  <a:schemeClr val="accent4">
+                    <a:lumMod val="60000"/>
+                    <a:lumOff val="40000"/>
+                  </a:schemeClr>
+                </a:solidFill>
+              </a:rPr>
+              <a:t>sender </a:t>
+            </a:r>
+            <a:br>
+              <a:rPr lang="sv-SE" sz="1600" dirty="0">
+                <a:solidFill>
+                  <a:schemeClr val="accent4">
+                    <a:lumMod val="60000"/>
+                    <a:lumOff val="40000"/>
+                  </a:schemeClr>
+                </a:solidFill>
+              </a:rPr>
+            </a:br>
+            <a:r>
+              <a:rPr lang="sv-SE" sz="1600" dirty="0">
+                <a:solidFill>
+                  <a:schemeClr val="accent4">
+                    <a:lumMod val="60000"/>
+                    <a:lumOff val="40000"/>
+                  </a:schemeClr>
+                </a:solidFill>
+              </a:rPr>
+              <a:t>port</a:t>
+            </a:r>
+            <a:endParaRPr lang="en-SE" sz="1600" dirty="0">
+              <a:solidFill>
+                <a:schemeClr val="accent4">
+                  <a:lumMod val="60000"/>
+                  <a:lumOff val="40000"/>
+                </a:schemeClr>
+              </a:solidFill>
+            </a:endParaRPr>
+          </a:p>
+        </p:txBody>
+      </p:sp>
+      <p:sp>
+        <p:nvSpPr>
+          <p:cNvPr id="12" name="TextBox 11">
+            <a:extLst>
+              <a:ext uri="{FF2B5EF4-FFF2-40B4-BE49-F238E27FC236}">
+                <a16:creationId xmlns:a16="http://schemas.microsoft.com/office/drawing/2014/main" id="{281D1303-2BDB-F94C-D3F1-52483FA5EDAA}"/>
+              </a:ext>
+            </a:extLst>
+          </p:cNvPr>
+          <p:cNvSpPr txBox="1"/>
+          <p:nvPr/>
+        </p:nvSpPr>
+        <p:spPr>
+          <a:xfrm>
+            <a:off x="3421061" y="2421944"/>
+            <a:ext cx="756938" cy="338554"/>
+          </a:xfrm>
+          <a:prstGeom prst="rect">
+            <a:avLst/>
+          </a:prstGeom>
+          <a:noFill/>
+        </p:spPr>
+        <p:txBody>
+          <a:bodyPr wrap="none" rtlCol="0">
+            <a:spAutoFit/>
+          </a:bodyPr>
+          <a:lstStyle/>
+          <a:p>
+            <a:r>
+              <a:rPr lang="sv-SE" sz="1600" dirty="0">
+                <a:solidFill>
+                  <a:schemeClr val="accent4">
+                    <a:lumMod val="60000"/>
+                    <a:lumOff val="40000"/>
+                  </a:schemeClr>
+                </a:solidFill>
+              </a:rPr>
+              <a:t>sender</a:t>
+            </a:r>
+            <a:endParaRPr lang="en-SE" sz="1600" dirty="0">
+              <a:solidFill>
+                <a:schemeClr val="accent4">
+                  <a:lumMod val="60000"/>
+                  <a:lumOff val="40000"/>
+                </a:schemeClr>
+              </a:solidFill>
+            </a:endParaRPr>
+          </a:p>
+        </p:txBody>
+      </p:sp>
+      <p:cxnSp>
+        <p:nvCxnSpPr>
+          <p:cNvPr id="13" name="Straight Arrow Connector 12">
+            <a:extLst>
+              <a:ext uri="{FF2B5EF4-FFF2-40B4-BE49-F238E27FC236}">
+                <a16:creationId xmlns:a16="http://schemas.microsoft.com/office/drawing/2014/main" id="{88746F23-5403-D30C-C0BD-772E32241109}"/>
+              </a:ext>
+            </a:extLst>
+          </p:cNvPr>
+          <p:cNvCxnSpPr>
+            <a:cxnSpLocks/>
+          </p:cNvCxnSpPr>
+          <p:nvPr/>
+        </p:nvCxnSpPr>
+        <p:spPr>
+          <a:xfrm flipV="1">
+            <a:off x="4879639" y="2219063"/>
+            <a:ext cx="0" cy="162253"/>
+          </a:xfrm>
+          <a:prstGeom prst="straightConnector1">
+            <a:avLst/>
+          </a:prstGeom>
+          <a:ln>
+            <a:solidFill>
+              <a:schemeClr val="accent4"/>
+            </a:solidFill>
+            <a:tailEnd type="triangle"/>
+          </a:ln>
+        </p:spPr>
+        <p:style>
+          <a:lnRef idx="1">
+            <a:schemeClr val="accent1"/>
+          </a:lnRef>
+          <a:fillRef idx="0">
+            <a:schemeClr val="accent1"/>
+          </a:fillRef>
+          <a:effectRef idx="0">
+            <a:schemeClr val="accent1"/>
+          </a:effectRef>
+          <a:fontRef idx="minor">
+            <a:schemeClr val="tx1"/>
+          </a:fontRef>
+        </p:style>
+      </p:cxnSp>
+      <p:sp>
+        <p:nvSpPr>
+          <p:cNvPr id="14" name="Right Brace 13">
+            <a:extLst>
+              <a:ext uri="{FF2B5EF4-FFF2-40B4-BE49-F238E27FC236}">
+                <a16:creationId xmlns:a16="http://schemas.microsoft.com/office/drawing/2014/main" id="{74287558-9420-85F0-6562-4E216E31EB3D}"/>
+              </a:ext>
+            </a:extLst>
+          </p:cNvPr>
+          <p:cNvSpPr/>
+          <p:nvPr/>
+        </p:nvSpPr>
+        <p:spPr>
+          <a:xfrm rot="5400000">
+            <a:off x="3673506" y="1651524"/>
+            <a:ext cx="218389" cy="1295261"/>
+          </a:xfrm>
+          <a:prstGeom prst="rightBrace">
+            <a:avLst/>
+          </a:prstGeom>
+        </p:spPr>
+        <p:style>
+          <a:lnRef idx="1">
+            <a:schemeClr val="accent4"/>
+          </a:lnRef>
+          <a:fillRef idx="0">
+            <a:schemeClr val="accent4"/>
+          </a:fillRef>
+          <a:effectRef idx="0">
+            <a:schemeClr val="accent4"/>
+          </a:effectRef>
+          <a:fontRef idx="minor">
+            <a:schemeClr val="tx1"/>
+          </a:fontRef>
+        </p:style>
+        <p:txBody>
+          <a:bodyPr rtlCol="0" anchor="ctr"/>
+          <a:lstStyle/>
+          <a:p>
+            <a:pPr algn="ctr"/>
+            <a:endParaRPr lang="en-SE"/>
+          </a:p>
+        </p:txBody>
+      </p:sp>
+      <p:sp>
+        <p:nvSpPr>
+          <p:cNvPr id="15" name="Right Brace 14">
+            <a:extLst>
+              <a:ext uri="{FF2B5EF4-FFF2-40B4-BE49-F238E27FC236}">
+                <a16:creationId xmlns:a16="http://schemas.microsoft.com/office/drawing/2014/main" id="{E5945647-D5F4-A167-063C-D23BCADA40E2}"/>
+              </a:ext>
+            </a:extLst>
+          </p:cNvPr>
+          <p:cNvSpPr/>
+          <p:nvPr/>
+        </p:nvSpPr>
+        <p:spPr>
+          <a:xfrm rot="16200000">
+            <a:off x="3673506" y="2272927"/>
+            <a:ext cx="218389" cy="1295261"/>
+          </a:xfrm>
+          <a:prstGeom prst="rightBrace">
+            <a:avLst/>
+          </a:prstGeom>
+        </p:spPr>
+        <p:style>
+          <a:lnRef idx="1">
+            <a:schemeClr val="accent4"/>
+          </a:lnRef>
+          <a:fillRef idx="0">
+            <a:schemeClr val="accent4"/>
+          </a:fillRef>
+          <a:effectRef idx="0">
+            <a:schemeClr val="accent4"/>
+          </a:effectRef>
+          <a:fontRef idx="minor">
+            <a:schemeClr val="tx1"/>
+          </a:fontRef>
+        </p:style>
+        <p:txBody>
+          <a:bodyPr rtlCol="0" anchor="ctr"/>
+          <a:lstStyle/>
+          <a:p>
+            <a:pPr algn="ctr"/>
+            <a:endParaRPr lang="en-SE"/>
+          </a:p>
+        </p:txBody>
+      </p:sp>
+      <p:sp>
+        <p:nvSpPr>
+          <p:cNvPr id="16" name="Right Brace 15">
+            <a:extLst>
+              <a:ext uri="{FF2B5EF4-FFF2-40B4-BE49-F238E27FC236}">
+                <a16:creationId xmlns:a16="http://schemas.microsoft.com/office/drawing/2014/main" id="{8CA8F20E-D216-B828-82AB-03E8C69F18F8}"/>
+              </a:ext>
+            </a:extLst>
+          </p:cNvPr>
+          <p:cNvSpPr/>
+          <p:nvPr/>
+        </p:nvSpPr>
+        <p:spPr>
+          <a:xfrm rot="5400000">
+            <a:off x="6136547" y="1664403"/>
+            <a:ext cx="218389" cy="1295261"/>
+          </a:xfrm>
+          <a:prstGeom prst="rightBrace">
+            <a:avLst/>
+          </a:prstGeom>
+        </p:spPr>
+        <p:style>
+          <a:lnRef idx="1">
+            <a:schemeClr val="accent4"/>
+          </a:lnRef>
+          <a:fillRef idx="0">
+            <a:schemeClr val="accent4"/>
+          </a:fillRef>
+          <a:effectRef idx="0">
+            <a:schemeClr val="accent4"/>
+          </a:effectRef>
+          <a:fontRef idx="minor">
+            <a:schemeClr val="tx1"/>
+          </a:fontRef>
+        </p:style>
+        <p:txBody>
+          <a:bodyPr rtlCol="0" anchor="ctr"/>
+          <a:lstStyle/>
+          <a:p>
+            <a:pPr algn="ctr"/>
+            <a:endParaRPr lang="en-SE"/>
+          </a:p>
+        </p:txBody>
+      </p:sp>
+      <p:sp>
+        <p:nvSpPr>
+          <p:cNvPr id="18" name="Right Brace 17">
+            <a:extLst>
+              <a:ext uri="{FF2B5EF4-FFF2-40B4-BE49-F238E27FC236}">
+                <a16:creationId xmlns:a16="http://schemas.microsoft.com/office/drawing/2014/main" id="{43A20254-0CD8-8C8A-19F2-3DBD7028E56E}"/>
+              </a:ext>
+            </a:extLst>
+          </p:cNvPr>
+          <p:cNvSpPr/>
+          <p:nvPr/>
+        </p:nvSpPr>
+        <p:spPr>
+          <a:xfrm rot="16200000">
+            <a:off x="5941728" y="2285805"/>
+            <a:ext cx="218389" cy="1295261"/>
+          </a:xfrm>
+          <a:prstGeom prst="rightBrace">
+            <a:avLst/>
+          </a:prstGeom>
+        </p:spPr>
+        <p:style>
+          <a:lnRef idx="1">
+            <a:schemeClr val="accent4"/>
+          </a:lnRef>
+          <a:fillRef idx="0">
+            <a:schemeClr val="accent4"/>
+          </a:fillRef>
+          <a:effectRef idx="0">
+            <a:schemeClr val="accent4"/>
+          </a:effectRef>
+          <a:fontRef idx="minor">
+            <a:schemeClr val="tx1"/>
+          </a:fontRef>
+        </p:style>
+        <p:txBody>
+          <a:bodyPr rtlCol="0" anchor="ctr"/>
+          <a:lstStyle/>
+          <a:p>
+            <a:pPr algn="ctr"/>
+            <a:endParaRPr lang="en-SE"/>
+          </a:p>
+        </p:txBody>
+      </p:sp>
+      <p:sp>
+        <p:nvSpPr>
+          <p:cNvPr id="36" name="TextBox 35">
+            <a:extLst>
+              <a:ext uri="{FF2B5EF4-FFF2-40B4-BE49-F238E27FC236}">
+                <a16:creationId xmlns:a16="http://schemas.microsoft.com/office/drawing/2014/main" id="{4E1F7BCA-BD7A-EAC6-CFB2-EDDC084A4615}"/>
+              </a:ext>
+            </a:extLst>
+          </p:cNvPr>
+          <p:cNvSpPr txBox="1"/>
+          <p:nvPr/>
+        </p:nvSpPr>
+        <p:spPr>
+          <a:xfrm>
+            <a:off x="6834871" y="2307600"/>
+            <a:ext cx="904543" cy="584775"/>
+          </a:xfrm>
+          <a:prstGeom prst="rect">
+            <a:avLst/>
+          </a:prstGeom>
+          <a:noFill/>
+        </p:spPr>
+        <p:txBody>
+          <a:bodyPr wrap="none" rtlCol="0">
+            <a:spAutoFit/>
+          </a:bodyPr>
+          <a:lstStyle/>
+          <a:p>
+            <a:pPr algn="ctr"/>
+            <a:r>
+              <a:rPr lang="sv-SE" sz="1600" dirty="0">
+                <a:solidFill>
+                  <a:schemeClr val="accent4">
+                    <a:lumMod val="60000"/>
+                    <a:lumOff val="40000"/>
+                  </a:schemeClr>
+                </a:solidFill>
+              </a:rPr>
+              <a:t>receiver </a:t>
+            </a:r>
+            <a:br>
+              <a:rPr lang="sv-SE" sz="1600" dirty="0">
+                <a:solidFill>
+                  <a:schemeClr val="accent4">
+                    <a:lumMod val="60000"/>
+                    <a:lumOff val="40000"/>
+                  </a:schemeClr>
+                </a:solidFill>
+              </a:rPr>
+            </a:br>
+            <a:r>
+              <a:rPr lang="sv-SE" sz="1600" dirty="0">
+                <a:solidFill>
+                  <a:schemeClr val="accent4">
+                    <a:lumMod val="60000"/>
+                    <a:lumOff val="40000"/>
+                  </a:schemeClr>
+                </a:solidFill>
+              </a:rPr>
+              <a:t>port</a:t>
+            </a:r>
+            <a:endParaRPr lang="en-SE" sz="1600" dirty="0">
+              <a:solidFill>
+                <a:schemeClr val="accent4">
+                  <a:lumMod val="60000"/>
+                  <a:lumOff val="40000"/>
+                </a:schemeClr>
+              </a:solidFill>
+            </a:endParaRPr>
+          </a:p>
+        </p:txBody>
+      </p:sp>
+      <p:cxnSp>
+        <p:nvCxnSpPr>
+          <p:cNvPr id="37" name="Straight Arrow Connector 36">
+            <a:extLst>
+              <a:ext uri="{FF2B5EF4-FFF2-40B4-BE49-F238E27FC236}">
+                <a16:creationId xmlns:a16="http://schemas.microsoft.com/office/drawing/2014/main" id="{9BE49A89-85C5-12B9-2D7B-B85335C6D4B0}"/>
+              </a:ext>
+            </a:extLst>
+          </p:cNvPr>
+          <p:cNvCxnSpPr>
+            <a:cxnSpLocks/>
+          </p:cNvCxnSpPr>
+          <p:nvPr/>
+        </p:nvCxnSpPr>
+        <p:spPr>
+          <a:xfrm flipV="1">
+            <a:off x="7263977" y="2207390"/>
+            <a:ext cx="0" cy="162253"/>
+          </a:xfrm>
+          <a:prstGeom prst="straightConnector1">
+            <a:avLst/>
+          </a:prstGeom>
+          <a:ln>
+            <a:solidFill>
+              <a:schemeClr val="accent4"/>
+            </a:solidFill>
+            <a:tailEnd type="triangle"/>
+          </a:ln>
+        </p:spPr>
+        <p:style>
+          <a:lnRef idx="1">
+            <a:schemeClr val="accent1"/>
+          </a:lnRef>
+          <a:fillRef idx="0">
+            <a:schemeClr val="accent1"/>
+          </a:fillRef>
+          <a:effectRef idx="0">
+            <a:schemeClr val="accent1"/>
+          </a:effectRef>
+          <a:fontRef idx="minor">
+            <a:schemeClr val="tx1"/>
+          </a:fontRef>
+        </p:style>
+      </p:cxnSp>
+      <p:sp>
+        <p:nvSpPr>
+          <p:cNvPr id="39" name="TextBox 38">
+            <a:extLst>
+              <a:ext uri="{FF2B5EF4-FFF2-40B4-BE49-F238E27FC236}">
+                <a16:creationId xmlns:a16="http://schemas.microsoft.com/office/drawing/2014/main" id="{569D9C6F-899B-83FC-17BB-657FF155345D}"/>
+              </a:ext>
+            </a:extLst>
+          </p:cNvPr>
+          <p:cNvSpPr txBox="1"/>
+          <p:nvPr/>
+        </p:nvSpPr>
+        <p:spPr>
+          <a:xfrm>
+            <a:off x="7657680" y="2421228"/>
+            <a:ext cx="654218" cy="338554"/>
+          </a:xfrm>
+          <a:prstGeom prst="rect">
+            <a:avLst/>
+          </a:prstGeom>
+          <a:noFill/>
+        </p:spPr>
+        <p:txBody>
+          <a:bodyPr wrap="none" rtlCol="0">
+            <a:spAutoFit/>
+          </a:bodyPr>
+          <a:lstStyle/>
+          <a:p>
+            <a:pPr algn="ctr"/>
+            <a:r>
+              <a:rPr lang="sv-SE" sz="1600" dirty="0">
+                <a:solidFill>
+                  <a:schemeClr val="accent4">
+                    <a:lumMod val="60000"/>
+                    <a:lumOff val="40000"/>
+                  </a:schemeClr>
+                </a:solidFill>
+              </a:rPr>
+              <a:t>event</a:t>
+            </a:r>
+            <a:endParaRPr lang="en-SE" sz="1600" dirty="0">
+              <a:solidFill>
+                <a:schemeClr val="accent4">
+                  <a:lumMod val="60000"/>
+                  <a:lumOff val="40000"/>
+                </a:schemeClr>
+              </a:solidFill>
+            </a:endParaRPr>
+          </a:p>
+        </p:txBody>
+      </p:sp>
+      <p:cxnSp>
+        <p:nvCxnSpPr>
+          <p:cNvPr id="40" name="Straight Arrow Connector 39">
+            <a:extLst>
+              <a:ext uri="{FF2B5EF4-FFF2-40B4-BE49-F238E27FC236}">
+                <a16:creationId xmlns:a16="http://schemas.microsoft.com/office/drawing/2014/main" id="{40E44B48-C9E1-EDFB-A306-EDFD924BE4A6}"/>
+              </a:ext>
+            </a:extLst>
+          </p:cNvPr>
+          <p:cNvCxnSpPr>
+            <a:cxnSpLocks/>
+          </p:cNvCxnSpPr>
+          <p:nvPr/>
+        </p:nvCxnSpPr>
+        <p:spPr>
+          <a:xfrm flipV="1">
+            <a:off x="7975669" y="2243869"/>
+            <a:ext cx="0" cy="162253"/>
+          </a:xfrm>
+          <a:prstGeom prst="straightConnector1">
+            <a:avLst/>
+          </a:prstGeom>
+          <a:ln>
+            <a:solidFill>
+              <a:schemeClr val="accent4"/>
+            </a:solidFill>
+            <a:tailEnd type="triangle"/>
+          </a:ln>
+        </p:spPr>
+        <p:style>
+          <a:lnRef idx="1">
+            <a:schemeClr val="accent1"/>
+          </a:lnRef>
+          <a:fillRef idx="0">
+            <a:schemeClr val="accent1"/>
+          </a:fillRef>
+          <a:effectRef idx="0">
+            <a:schemeClr val="accent1"/>
+          </a:effectRef>
+          <a:fontRef idx="minor">
+            <a:schemeClr val="tx1"/>
+          </a:fontRef>
+        </p:style>
+      </p:cxnSp>
+      <p:cxnSp>
+        <p:nvCxnSpPr>
+          <p:cNvPr id="44" name="Straight Arrow Connector 43">
+            <a:extLst>
+              <a:ext uri="{FF2B5EF4-FFF2-40B4-BE49-F238E27FC236}">
+                <a16:creationId xmlns:a16="http://schemas.microsoft.com/office/drawing/2014/main" id="{DCF169A3-7B6D-C7EA-04DC-305ADB48C361}"/>
+              </a:ext>
+            </a:extLst>
+          </p:cNvPr>
+          <p:cNvCxnSpPr>
+            <a:cxnSpLocks/>
+          </p:cNvCxnSpPr>
+          <p:nvPr/>
+        </p:nvCxnSpPr>
+        <p:spPr>
+          <a:xfrm>
+            <a:off x="7270414" y="2838587"/>
+            <a:ext cx="0" cy="191549"/>
+          </a:xfrm>
+          <a:prstGeom prst="straightConnector1">
+            <a:avLst/>
+          </a:prstGeom>
+          <a:ln>
+            <a:solidFill>
+              <a:schemeClr val="accent4"/>
+            </a:solidFill>
+            <a:tailEnd type="triangle"/>
+          </a:ln>
+        </p:spPr>
+        <p:style>
+          <a:lnRef idx="1">
+            <a:schemeClr val="accent1"/>
+          </a:lnRef>
+          <a:fillRef idx="0">
+            <a:schemeClr val="accent1"/>
+          </a:fillRef>
+          <a:effectRef idx="0">
+            <a:schemeClr val="accent1"/>
+          </a:effectRef>
+          <a:fontRef idx="minor">
+            <a:schemeClr val="tx1"/>
+          </a:fontRef>
+        </p:style>
+      </p:cxnSp>
+      <p:cxnSp>
+        <p:nvCxnSpPr>
+          <p:cNvPr id="45" name="Straight Arrow Connector 44">
+            <a:extLst>
+              <a:ext uri="{FF2B5EF4-FFF2-40B4-BE49-F238E27FC236}">
+                <a16:creationId xmlns:a16="http://schemas.microsoft.com/office/drawing/2014/main" id="{DD7ABB01-5CCF-E583-D567-E1AF739B9794}"/>
+              </a:ext>
+            </a:extLst>
+          </p:cNvPr>
+          <p:cNvCxnSpPr>
+            <a:cxnSpLocks/>
+          </p:cNvCxnSpPr>
+          <p:nvPr/>
+        </p:nvCxnSpPr>
+        <p:spPr>
+          <a:xfrm>
+            <a:off x="7984789" y="2838587"/>
+            <a:ext cx="0" cy="191549"/>
+          </a:xfrm>
+          <a:prstGeom prst="straightConnector1">
+            <a:avLst/>
+          </a:prstGeom>
+          <a:ln>
+            <a:solidFill>
+              <a:schemeClr val="accent4"/>
+            </a:solidFill>
+            <a:tailEnd type="triangle"/>
+          </a:ln>
+        </p:spPr>
+        <p:style>
+          <a:lnRef idx="1">
+            <a:schemeClr val="accent1"/>
+          </a:lnRef>
+          <a:fillRef idx="0">
+            <a:schemeClr val="accent1"/>
+          </a:fillRef>
+          <a:effectRef idx="0">
+            <a:schemeClr val="accent1"/>
+          </a:effectRef>
+          <a:fontRef idx="minor">
+            <a:schemeClr val="tx1"/>
+          </a:fontRef>
+        </p:style>
+      </p:cxnSp>
+      <p:sp>
+        <p:nvSpPr>
+          <p:cNvPr id="46" name="TextBox 45">
+            <a:extLst>
+              <a:ext uri="{FF2B5EF4-FFF2-40B4-BE49-F238E27FC236}">
+                <a16:creationId xmlns:a16="http://schemas.microsoft.com/office/drawing/2014/main" id="{F5C52908-08C2-7E0C-E6E4-F7CAC60524EE}"/>
+              </a:ext>
+            </a:extLst>
+          </p:cNvPr>
+          <p:cNvSpPr txBox="1"/>
+          <p:nvPr/>
+        </p:nvSpPr>
+        <p:spPr>
+          <a:xfrm>
+            <a:off x="8245325" y="2430711"/>
+            <a:ext cx="552139" cy="338554"/>
+          </a:xfrm>
+          <a:prstGeom prst="rect">
+            <a:avLst/>
+          </a:prstGeom>
+          <a:noFill/>
+        </p:spPr>
+        <p:txBody>
+          <a:bodyPr wrap="none" rtlCol="0">
+            <a:spAutoFit/>
+          </a:bodyPr>
+          <a:lstStyle/>
+          <a:p>
+            <a:pPr algn="ctr"/>
+            <a:r>
+              <a:rPr lang="sv-SE" sz="1600" dirty="0">
+                <a:solidFill>
+                  <a:schemeClr val="accent4">
+                    <a:lumMod val="60000"/>
+                    <a:lumOff val="40000"/>
+                  </a:schemeClr>
+                </a:solidFill>
+              </a:rPr>
+              <a:t>data</a:t>
+            </a:r>
+            <a:endParaRPr lang="en-SE" sz="1600" dirty="0">
+              <a:solidFill>
+                <a:schemeClr val="accent4">
+                  <a:lumMod val="60000"/>
+                  <a:lumOff val="40000"/>
+                </a:schemeClr>
+              </a:solidFill>
+            </a:endParaRPr>
+          </a:p>
+        </p:txBody>
+      </p:sp>
+      <p:cxnSp>
+        <p:nvCxnSpPr>
+          <p:cNvPr id="47" name="Straight Arrow Connector 46">
+            <a:extLst>
+              <a:ext uri="{FF2B5EF4-FFF2-40B4-BE49-F238E27FC236}">
+                <a16:creationId xmlns:a16="http://schemas.microsoft.com/office/drawing/2014/main" id="{CADD3199-B912-0D39-9B18-679822BAADE3}"/>
+              </a:ext>
+            </a:extLst>
+          </p:cNvPr>
+          <p:cNvCxnSpPr>
+            <a:cxnSpLocks/>
+            <a:stCxn id="46" idx="0"/>
+          </p:cNvCxnSpPr>
+          <p:nvPr/>
+        </p:nvCxnSpPr>
+        <p:spPr>
+          <a:xfrm flipH="1" flipV="1">
+            <a:off x="8382000" y="2243869"/>
+            <a:ext cx="139395" cy="186842"/>
+          </a:xfrm>
+          <a:prstGeom prst="straightConnector1">
+            <a:avLst/>
+          </a:prstGeom>
+          <a:ln>
+            <a:solidFill>
+              <a:schemeClr val="accent4"/>
+            </a:solidFill>
+            <a:tailEnd type="triangle"/>
+          </a:ln>
+        </p:spPr>
+        <p:style>
+          <a:lnRef idx="1">
+            <a:schemeClr val="accent1"/>
+          </a:lnRef>
+          <a:fillRef idx="0">
+            <a:schemeClr val="accent1"/>
+          </a:fillRef>
+          <a:effectRef idx="0">
+            <a:schemeClr val="accent1"/>
+          </a:effectRef>
+          <a:fontRef idx="minor">
+            <a:schemeClr val="tx1"/>
+          </a:fontRef>
+        </p:style>
+      </p:cxnSp>
+    </p:spTree>
+    <p:extLst>
+      <p:ext uri="{BB962C8B-B14F-4D97-AF65-F5344CB8AC3E}">
+        <p14:creationId xmlns:p14="http://schemas.microsoft.com/office/powerpoint/2010/main" val="685382527"/>
+      </p:ext>
+    </p:extLst>
+  </p:cSld>
+  <p:clrMapOvr>
+    <a:masterClrMapping/>
+  </p:clrMapOvr>
+</p:sld>
+</file>
+
 <file path=ppt/slides/slide4.xml><?xml version="1.0" encoding="utf-8"?>
 <p:sld xmlns:a="http://schemas.openxmlformats.org/drawingml/2006/main" xmlns:r="http://schemas.openxmlformats.org/officeDocument/2006/relationships" xmlns:p="http://schemas.openxmlformats.org/presentationml/2006/main">
   <p:cSld>

</xml_diff>